<commit_message>
Add trained vault scoring model
</commit_message>
<xml_diff>
--- a/VaultLab_Presentation.pptx
+++ b/VaultLab_Presentation.pptx
@@ -2,21 +2,21 @@
 <file path=ppt/presentation.xml><?xml version="1.0" encoding="utf-8"?>
 <p:presentation xmlns:p="http://schemas.openxmlformats.org/presentationml/2006/main">
   <p:sldMasterIdLst>
-    <p:sldMasterId xmlns:r="http://schemas.openxmlformats.org/officeDocument/2006/relationships" id="2147483648" r:id="R03ef5249cda7449a"/>
+    <p:sldMasterId xmlns:r="http://schemas.openxmlformats.org/officeDocument/2006/relationships" id="2147483648" r:id="R1ae3dd5fcc6646b5"/>
   </p:sldMasterIdLst>
   <p:notesMasterIdLst>
-    <p:notesMasterId xmlns:r="http://schemas.openxmlformats.org/officeDocument/2006/relationships" r:id="R1b6db36539934b40"/>
+    <p:notesMasterId xmlns:r="http://schemas.openxmlformats.org/officeDocument/2006/relationships" r:id="R3e949d0cb5db4118"/>
   </p:notesMasterIdLst>
   <p:sldIdLst>
-    <p:sldId xmlns:r="http://schemas.openxmlformats.org/officeDocument/2006/relationships" id="256" r:id="Rac024674422f49c2"/>
-    <p:sldId xmlns:r="http://schemas.openxmlformats.org/officeDocument/2006/relationships" id="257" r:id="Rae6ad11aeaba4e4f"/>
-    <p:sldId xmlns:r="http://schemas.openxmlformats.org/officeDocument/2006/relationships" id="258" r:id="R643e6f39ee21438a"/>
-    <p:sldId xmlns:r="http://schemas.openxmlformats.org/officeDocument/2006/relationships" id="259" r:id="R5b35ce5d00864db7"/>
-    <p:sldId xmlns:r="http://schemas.openxmlformats.org/officeDocument/2006/relationships" id="260" r:id="R5aa2802dab4a4d64"/>
-    <p:sldId xmlns:r="http://schemas.openxmlformats.org/officeDocument/2006/relationships" id="261" r:id="R362043fa61384098"/>
-    <p:sldId xmlns:r="http://schemas.openxmlformats.org/officeDocument/2006/relationships" id="262" r:id="R115546f4b43f45d6"/>
-    <p:sldId xmlns:r="http://schemas.openxmlformats.org/officeDocument/2006/relationships" id="263" r:id="R5ee25a35f537488c"/>
-    <p:sldId xmlns:r="http://schemas.openxmlformats.org/officeDocument/2006/relationships" id="264" r:id="R83693ee8da7e4ffe"/>
+    <p:sldId xmlns:r="http://schemas.openxmlformats.org/officeDocument/2006/relationships" id="256" r:id="R79f22fbe08724666"/>
+    <p:sldId xmlns:r="http://schemas.openxmlformats.org/officeDocument/2006/relationships" id="257" r:id="R4b14aa87f75a4c77"/>
+    <p:sldId xmlns:r="http://schemas.openxmlformats.org/officeDocument/2006/relationships" id="258" r:id="Rc3c6394564464f7e"/>
+    <p:sldId xmlns:r="http://schemas.openxmlformats.org/officeDocument/2006/relationships" id="259" r:id="R625afd5e197143ef"/>
+    <p:sldId xmlns:r="http://schemas.openxmlformats.org/officeDocument/2006/relationships" id="260" r:id="R12aaad06a5704f1a"/>
+    <p:sldId xmlns:r="http://schemas.openxmlformats.org/officeDocument/2006/relationships" id="261" r:id="R5e2fb882a0f545b8"/>
+    <p:sldId xmlns:r="http://schemas.openxmlformats.org/officeDocument/2006/relationships" id="262" r:id="R2500b1d8a29049ec"/>
+    <p:sldId xmlns:r="http://schemas.openxmlformats.org/officeDocument/2006/relationships" id="263" r:id="R99a00153b67c46b9"/>
+    <p:sldId xmlns:r="http://schemas.openxmlformats.org/officeDocument/2006/relationships" id="264" r:id="R8694f7b79c314d7c"/>
   </p:sldIdLst>
   <p:sldSz cx="12192000" cy="6858000"/>
   <p:notesSz cx="6858000" cy="9144000"/>
@@ -1098,7 +1098,7 @@
   </p:cSld>
   <p:clrMap bg1="lt1" tx1="dk1" bg2="lt2" tx2="dk2" accent1="accent1" accent2="accent2" accent3="accent3" accent4="accent4" accent5="accent5" accent6="accent6" hlink="hlink" folHlink="folHlink"/>
   <p:sldLayoutIdLst>
-    <p:sldLayoutId xmlns:r="http://schemas.openxmlformats.org/officeDocument/2006/relationships" id="2147483649" r:id="Rdf3f837c1efd4366"/>
+    <p:sldLayoutId xmlns:r="http://schemas.openxmlformats.org/officeDocument/2006/relationships" id="2147483649" r:id="R50cddf819da7475c"/>
   </p:sldLayoutIdLst>
   <p:txStyles>
     <p:titleStyle>
@@ -1649,7 +1649,7 @@
           <p:cNvPr id="8" name="">
             <a:extLst xmlns:a="http://schemas.openxmlformats.org/drawingml/2006/main">
               <a:ext uri="{FF2B5EF4-FFF2-40B4-BE49-F238E27FC236}">
-                <a16:creationId xmlns:a16="http://schemas.microsoft.com/office/drawing/2014/main" id="{5FDBBC54-75D4-45BE-AEC8-D47C5BCEDFEA}"/>
+                <a16:creationId xmlns:a16="http://schemas.microsoft.com/office/drawing/2014/main" id="{E4487CE1-44A9-428C-BA43-F79AEB1E0614}"/>
               </a:ext>
             </a:extLst>
           </p:cNvPr>
@@ -1699,7 +1699,7 @@
           <p:cNvPr id="2" name="">
             <a:extLst xmlns:a="http://schemas.openxmlformats.org/drawingml/2006/main">
               <a:ext uri="{FF2B5EF4-FFF2-40B4-BE49-F238E27FC236}">
-                <a16:creationId xmlns:a16="http://schemas.microsoft.com/office/drawing/2014/main" id="{B0663F5A-C817-4CC0-860F-3F871EF5138E}"/>
+                <a16:creationId xmlns:a16="http://schemas.microsoft.com/office/drawing/2014/main" id="{4D538D11-2896-4750-8A4C-099E1C72AD81}"/>
               </a:ext>
             </a:extLst>
           </p:cNvPr>
@@ -1749,7 +1749,7 @@
           <p:cNvPr id="3" name="">
             <a:extLst xmlns:a="http://schemas.openxmlformats.org/drawingml/2006/main">
               <a:ext uri="{FF2B5EF4-FFF2-40B4-BE49-F238E27FC236}">
-                <a16:creationId xmlns:a16="http://schemas.microsoft.com/office/drawing/2014/main" id="{94D7DF47-BB4D-4A76-BFD4-996BA8A79A4C}"/>
+                <a16:creationId xmlns:a16="http://schemas.microsoft.com/office/drawing/2014/main" id="{597CF98A-0F34-4C80-AB32-FFA85D804F01}"/>
               </a:ext>
             </a:extLst>
           </p:cNvPr>
@@ -1782,7 +1782,7 @@
           <p:cNvPr id="4" name="">
             <a:extLst xmlns:a="http://schemas.openxmlformats.org/drawingml/2006/main">
               <a:ext uri="{FF2B5EF4-FFF2-40B4-BE49-F238E27FC236}">
-                <a16:creationId xmlns:a16="http://schemas.microsoft.com/office/drawing/2014/main" id="{5B0C77DC-B220-420B-99B7-46C80865A952}"/>
+                <a16:creationId xmlns:a16="http://schemas.microsoft.com/office/drawing/2014/main" id="{9AC9AA07-4A40-47F2-9CC4-291E3CBC66A3}"/>
               </a:ext>
             </a:extLst>
           </p:cNvPr>
@@ -1832,7 +1832,7 @@
           <p:cNvPr id="5" name="">
             <a:extLst xmlns:a="http://schemas.openxmlformats.org/drawingml/2006/main">
               <a:ext uri="{FF2B5EF4-FFF2-40B4-BE49-F238E27FC236}">
-                <a16:creationId xmlns:a16="http://schemas.microsoft.com/office/drawing/2014/main" id="{E1CD4E05-E859-4554-A829-C6FF9007C90B}"/>
+                <a16:creationId xmlns:a16="http://schemas.microsoft.com/office/drawing/2014/main" id="{A0A9FB1F-19C7-4D6D-A35C-E7A25BB4996E}"/>
               </a:ext>
             </a:extLst>
           </p:cNvPr>
@@ -1899,7 +1899,7 @@
           <p:cNvPr id="6" name="">
             <a:extLst xmlns:a="http://schemas.openxmlformats.org/drawingml/2006/main">
               <a:ext uri="{FF2B5EF4-FFF2-40B4-BE49-F238E27FC236}">
-                <a16:creationId xmlns:a16="http://schemas.microsoft.com/office/drawing/2014/main" id="{AA4A7AED-3F9C-4898-ADF2-2E99088207DF}"/>
+                <a16:creationId xmlns:a16="http://schemas.microsoft.com/office/drawing/2014/main" id="{681545E6-C1A1-4E98-BD34-EC32467AAF7D}"/>
               </a:ext>
             </a:extLst>
           </p:cNvPr>
@@ -1949,7 +1949,7 @@
           <p:cNvPr id="7" name="">
             <a:extLst xmlns:a="http://schemas.openxmlformats.org/drawingml/2006/main">
               <a:ext uri="{FF2B5EF4-FFF2-40B4-BE49-F238E27FC236}">
-                <a16:creationId xmlns:a16="http://schemas.microsoft.com/office/drawing/2014/main" id="{6B5AC95E-1FED-4607-8167-DA8196E637FF}"/>
+                <a16:creationId xmlns:a16="http://schemas.microsoft.com/office/drawing/2014/main" id="{5CFA9CC9-7497-4A17-9FC5-83A3758231DA}"/>
               </a:ext>
             </a:extLst>
           </p:cNvPr>
@@ -1997,7 +1997,7 @@
     </p:spTree>
     <p:extLst>
       <p:ext uri="{BB962C8B-B14F-4D97-AF65-F5344CB8AC3E}">
-        <p14:creationId xmlns:p14="http://schemas.microsoft.com/office/powerpoint/2010/main" val="1390175715"/>
+        <p14:creationId xmlns:p14="http://schemas.microsoft.com/office/powerpoint/2010/main" val="635906087"/>
       </p:ext>
     </p:extLst>
   </p:cSld>
@@ -2028,7 +2028,7 @@
           <p:cNvPr id="16" name="">
             <a:extLst xmlns:a="http://schemas.openxmlformats.org/drawingml/2006/main">
               <a:ext uri="{FF2B5EF4-FFF2-40B4-BE49-F238E27FC236}">
-                <a16:creationId xmlns:a16="http://schemas.microsoft.com/office/drawing/2014/main" id="{66BF8031-4FCD-4F1C-A528-48AE09191632}"/>
+                <a16:creationId xmlns:a16="http://schemas.microsoft.com/office/drawing/2014/main" id="{28FAC3B0-C679-4DE3-AE41-354BC26200C6}"/>
               </a:ext>
             </a:extLst>
           </p:cNvPr>
@@ -2078,7 +2078,7 @@
           <p:cNvPr id="2" name="">
             <a:extLst xmlns:a="http://schemas.openxmlformats.org/drawingml/2006/main">
               <a:ext uri="{FF2B5EF4-FFF2-40B4-BE49-F238E27FC236}">
-                <a16:creationId xmlns:a16="http://schemas.microsoft.com/office/drawing/2014/main" id="{0094E26B-7453-4755-ACD9-12F90FB1BEFC}"/>
+                <a16:creationId xmlns:a16="http://schemas.microsoft.com/office/drawing/2014/main" id="{1E1924D0-811B-475C-8BF4-1E57F60A2D40}"/>
               </a:ext>
             </a:extLst>
           </p:cNvPr>
@@ -2111,7 +2111,7 @@
           <p:cNvPr id="3" name="">
             <a:extLst xmlns:a="http://schemas.openxmlformats.org/drawingml/2006/main">
               <a:ext uri="{FF2B5EF4-FFF2-40B4-BE49-F238E27FC236}">
-                <a16:creationId xmlns:a16="http://schemas.microsoft.com/office/drawing/2014/main" id="{B1C1D5A4-A0B0-47F7-A5C3-E3AA7D9FEC1A}"/>
+                <a16:creationId xmlns:a16="http://schemas.microsoft.com/office/drawing/2014/main" id="{047B06D9-8013-4AE3-B5A0-16FC465DBCF7}"/>
               </a:ext>
             </a:extLst>
           </p:cNvPr>
@@ -2144,7 +2144,7 @@
           <p:cNvPr id="4" name="">
             <a:extLst xmlns:a="http://schemas.openxmlformats.org/drawingml/2006/main">
               <a:ext uri="{FF2B5EF4-FFF2-40B4-BE49-F238E27FC236}">
-                <a16:creationId xmlns:a16="http://schemas.microsoft.com/office/drawing/2014/main" id="{E612EDBF-760E-4358-A10A-FED8351A21B6}"/>
+                <a16:creationId xmlns:a16="http://schemas.microsoft.com/office/drawing/2014/main" id="{35FD27CC-DFE6-467C-812B-856B13541407}"/>
               </a:ext>
             </a:extLst>
           </p:cNvPr>
@@ -2194,7 +2194,7 @@
           <p:cNvPr id="5" name="">
             <a:extLst xmlns:a="http://schemas.openxmlformats.org/drawingml/2006/main">
               <a:ext uri="{FF2B5EF4-FFF2-40B4-BE49-F238E27FC236}">
-                <a16:creationId xmlns:a16="http://schemas.microsoft.com/office/drawing/2014/main" id="{D9ED755C-B681-4A34-8DC7-ABD132D822B5}"/>
+                <a16:creationId xmlns:a16="http://schemas.microsoft.com/office/drawing/2014/main" id="{48F17637-FA8F-456C-8C8C-AFD920B9CF56}"/>
               </a:ext>
             </a:extLst>
           </p:cNvPr>
@@ -2227,7 +2227,7 @@
           <p:cNvPr id="6" name="">
             <a:extLst xmlns:a="http://schemas.openxmlformats.org/drawingml/2006/main">
               <a:ext uri="{FF2B5EF4-FFF2-40B4-BE49-F238E27FC236}">
-                <a16:creationId xmlns:a16="http://schemas.microsoft.com/office/drawing/2014/main" id="{F730DE7C-023E-4A2F-A450-A2B7CA69A9FA}"/>
+                <a16:creationId xmlns:a16="http://schemas.microsoft.com/office/drawing/2014/main" id="{2EDFC220-10D5-46B3-B29D-7021338EC203}"/>
               </a:ext>
             </a:extLst>
           </p:cNvPr>
@@ -2277,7 +2277,7 @@
           <p:cNvPr id="7" name="">
             <a:extLst xmlns:a="http://schemas.openxmlformats.org/drawingml/2006/main">
               <a:ext uri="{FF2B5EF4-FFF2-40B4-BE49-F238E27FC236}">
-                <a16:creationId xmlns:a16="http://schemas.microsoft.com/office/drawing/2014/main" id="{45CEF228-9BEC-4B0A-A454-3DBA2A4D7E97}"/>
+                <a16:creationId xmlns:a16="http://schemas.microsoft.com/office/drawing/2014/main" id="{09F6F1C7-E5ED-4F4B-9428-53EF2F664BEC}"/>
               </a:ext>
             </a:extLst>
           </p:cNvPr>
@@ -2310,7 +2310,7 @@
           <p:cNvPr id="8" name="">
             <a:extLst xmlns:a="http://schemas.openxmlformats.org/drawingml/2006/main">
               <a:ext uri="{FF2B5EF4-FFF2-40B4-BE49-F238E27FC236}">
-                <a16:creationId xmlns:a16="http://schemas.microsoft.com/office/drawing/2014/main" id="{50355713-76DC-4FE6-AD7B-97ECFD5E3D2C}"/>
+                <a16:creationId xmlns:a16="http://schemas.microsoft.com/office/drawing/2014/main" id="{A88A18FA-9690-4E36-B566-ED490A8AB889}"/>
               </a:ext>
             </a:extLst>
           </p:cNvPr>
@@ -2360,7 +2360,7 @@
           <p:cNvPr id="9" name="">
             <a:extLst xmlns:a="http://schemas.openxmlformats.org/drawingml/2006/main">
               <a:ext uri="{FF2B5EF4-FFF2-40B4-BE49-F238E27FC236}">
-                <a16:creationId xmlns:a16="http://schemas.microsoft.com/office/drawing/2014/main" id="{88CE6CB5-0A97-40D5-9249-132DE00CC5B9}"/>
+                <a16:creationId xmlns:a16="http://schemas.microsoft.com/office/drawing/2014/main" id="{5ED04371-F340-4E84-8A63-A65F61F4EBDF}"/>
               </a:ext>
             </a:extLst>
           </p:cNvPr>
@@ -2393,7 +2393,7 @@
           <p:cNvPr id="10" name="">
             <a:extLst xmlns:a="http://schemas.openxmlformats.org/drawingml/2006/main">
               <a:ext uri="{FF2B5EF4-FFF2-40B4-BE49-F238E27FC236}">
-                <a16:creationId xmlns:a16="http://schemas.microsoft.com/office/drawing/2014/main" id="{C7392CE6-5E73-4414-ABCE-86E7D99070DD}"/>
+                <a16:creationId xmlns:a16="http://schemas.microsoft.com/office/drawing/2014/main" id="{5322FCC9-FECC-4C7C-A93A-7A2DF287A1CA}"/>
               </a:ext>
             </a:extLst>
           </p:cNvPr>
@@ -2443,7 +2443,7 @@
           <p:cNvPr id="11" name="">
             <a:extLst xmlns:a="http://schemas.openxmlformats.org/drawingml/2006/main">
               <a:ext uri="{FF2B5EF4-FFF2-40B4-BE49-F238E27FC236}">
-                <a16:creationId xmlns:a16="http://schemas.microsoft.com/office/drawing/2014/main" id="{63527A0A-24A3-4E73-9DED-46FC7C50D4D5}"/>
+                <a16:creationId xmlns:a16="http://schemas.microsoft.com/office/drawing/2014/main" id="{F90A71F5-75B2-4983-948D-BB487537EC5D}"/>
               </a:ext>
             </a:extLst>
           </p:cNvPr>
@@ -2493,7 +2493,7 @@
           <p:cNvPr id="12" name="">
             <a:extLst xmlns:a="http://schemas.openxmlformats.org/drawingml/2006/main">
               <a:ext uri="{FF2B5EF4-FFF2-40B4-BE49-F238E27FC236}">
-                <a16:creationId xmlns:a16="http://schemas.microsoft.com/office/drawing/2014/main" id="{365C9A97-9B94-4916-A00F-7469FAFF2D7A}"/>
+                <a16:creationId xmlns:a16="http://schemas.microsoft.com/office/drawing/2014/main" id="{85099A0E-DF67-4DF3-A2CA-8C4E049E2B06}"/>
               </a:ext>
             </a:extLst>
           </p:cNvPr>
@@ -2526,7 +2526,7 @@
           <p:cNvPr id="13" name="">
             <a:extLst xmlns:a="http://schemas.openxmlformats.org/drawingml/2006/main">
               <a:ext uri="{FF2B5EF4-FFF2-40B4-BE49-F238E27FC236}">
-                <a16:creationId xmlns:a16="http://schemas.microsoft.com/office/drawing/2014/main" id="{D8BABCF7-2A50-4672-AEB9-33440924F1E5}"/>
+                <a16:creationId xmlns:a16="http://schemas.microsoft.com/office/drawing/2014/main" id="{CDBCC484-630F-46D2-AAE9-A47C59A8FFE3}"/>
               </a:ext>
             </a:extLst>
           </p:cNvPr>
@@ -2576,7 +2576,7 @@
           <p:cNvPr id="14" name="">
             <a:extLst xmlns:a="http://schemas.openxmlformats.org/drawingml/2006/main">
               <a:ext uri="{FF2B5EF4-FFF2-40B4-BE49-F238E27FC236}">
-                <a16:creationId xmlns:a16="http://schemas.microsoft.com/office/drawing/2014/main" id="{5390FEC2-E6C6-42AA-8F4F-6BCBD886E5A5}"/>
+                <a16:creationId xmlns:a16="http://schemas.microsoft.com/office/drawing/2014/main" id="{C975793F-39A0-4642-AB32-E58D5F533EF0}"/>
               </a:ext>
             </a:extLst>
           </p:cNvPr>
@@ -2626,7 +2626,7 @@
           <p:cNvPr id="15" name="">
             <a:extLst xmlns:a="http://schemas.openxmlformats.org/drawingml/2006/main">
               <a:ext uri="{FF2B5EF4-FFF2-40B4-BE49-F238E27FC236}">
-                <a16:creationId xmlns:a16="http://schemas.microsoft.com/office/drawing/2014/main" id="{CBEA0D5E-5F1B-4AF8-8C38-77ACDFC4B719}"/>
+                <a16:creationId xmlns:a16="http://schemas.microsoft.com/office/drawing/2014/main" id="{98209887-69FE-42FC-91F4-FEC355E7E1D2}"/>
               </a:ext>
             </a:extLst>
           </p:cNvPr>
@@ -2674,7 +2674,7 @@
     </p:spTree>
     <p:extLst>
       <p:ext uri="{BB962C8B-B14F-4D97-AF65-F5344CB8AC3E}">
-        <p14:creationId xmlns:p14="http://schemas.microsoft.com/office/powerpoint/2010/main" val="308388592"/>
+        <p14:creationId xmlns:p14="http://schemas.microsoft.com/office/powerpoint/2010/main" val="811402783"/>
       </p:ext>
     </p:extLst>
   </p:cSld>
@@ -2705,7 +2705,7 @@
           <p:cNvPr id="7" name="">
             <a:extLst xmlns:a="http://schemas.openxmlformats.org/drawingml/2006/main">
               <a:ext uri="{FF2B5EF4-FFF2-40B4-BE49-F238E27FC236}">
-                <a16:creationId xmlns:a16="http://schemas.microsoft.com/office/drawing/2014/main" id="{3046FEB2-E50E-4661-A006-1594C17797CA}"/>
+                <a16:creationId xmlns:a16="http://schemas.microsoft.com/office/drawing/2014/main" id="{41E37BC5-CA11-4EF6-BD10-520982E4C007}"/>
               </a:ext>
             </a:extLst>
           </p:cNvPr>
@@ -2755,7 +2755,7 @@
           <p:cNvPr id="2" name="">
             <a:extLst xmlns:a="http://schemas.openxmlformats.org/drawingml/2006/main">
               <a:ext uri="{FF2B5EF4-FFF2-40B4-BE49-F238E27FC236}">
-                <a16:creationId xmlns:a16="http://schemas.microsoft.com/office/drawing/2014/main" id="{F64E3196-524E-44C7-BE85-A58D88CAEB99}"/>
+                <a16:creationId xmlns:a16="http://schemas.microsoft.com/office/drawing/2014/main" id="{ED32D503-1A09-414A-93F5-2C7DEA68F0EC}"/>
               </a:ext>
             </a:extLst>
           </p:cNvPr>
@@ -2788,7 +2788,7 @@
           <p:cNvPr id="3" name="">
             <a:extLst xmlns:a="http://schemas.openxmlformats.org/drawingml/2006/main">
               <a:ext uri="{FF2B5EF4-FFF2-40B4-BE49-F238E27FC236}">
-                <a16:creationId xmlns:a16="http://schemas.microsoft.com/office/drawing/2014/main" id="{A4E1DBB6-EF1D-4435-AE81-0440E1B8A57A}"/>
+                <a16:creationId xmlns:a16="http://schemas.microsoft.com/office/drawing/2014/main" id="{78F21B10-8467-4852-A281-34CBA9EA9CDB}"/>
               </a:ext>
             </a:extLst>
           </p:cNvPr>
@@ -2838,7 +2838,7 @@
           <p:cNvPr id="4" name="">
             <a:extLst xmlns:a="http://schemas.openxmlformats.org/drawingml/2006/main">
               <a:ext uri="{FF2B5EF4-FFF2-40B4-BE49-F238E27FC236}">
-                <a16:creationId xmlns:a16="http://schemas.microsoft.com/office/drawing/2014/main" id="{BBB4BCDC-44EF-452D-9576-D9C3A7C37645}"/>
+                <a16:creationId xmlns:a16="http://schemas.microsoft.com/office/drawing/2014/main" id="{A622F0FF-9DEE-4990-8100-CA123908FB75}"/>
               </a:ext>
             </a:extLst>
           </p:cNvPr>
@@ -2871,7 +2871,7 @@
           <p:cNvPr id="5" name="">
             <a:extLst xmlns:a="http://schemas.openxmlformats.org/drawingml/2006/main">
               <a:ext uri="{FF2B5EF4-FFF2-40B4-BE49-F238E27FC236}">
-                <a16:creationId xmlns:a16="http://schemas.microsoft.com/office/drawing/2014/main" id="{851FC954-1682-41B5-8A0B-09AFCCD9E0B4}"/>
+                <a16:creationId xmlns:a16="http://schemas.microsoft.com/office/drawing/2014/main" id="{595B5B9B-79D7-43BA-9607-C084F170A0C3}"/>
               </a:ext>
             </a:extLst>
           </p:cNvPr>
@@ -2911,7 +2911,7 @@
                   <a:srgbClr val="111827"/>
                 </a:solidFill>
               </a:rPr>
-              <a:t>Planned model: logistic regression because the target label is binary: make or miss.</a:t>
+              <a:t>Model: logistic regression trained from labeled makes and misses because the target is binary.</a:t>
             </a:r>
           </a:p>
         </p:txBody>
@@ -2921,7 +2921,7 @@
           <p:cNvPr id="6" name="">
             <a:extLst xmlns:a="http://schemas.openxmlformats.org/drawingml/2006/main">
               <a:ext uri="{FF2B5EF4-FFF2-40B4-BE49-F238E27FC236}">
-                <a16:creationId xmlns:a16="http://schemas.microsoft.com/office/drawing/2014/main" id="{9B87ADE4-6E26-49B9-8B19-68B73BF2CF6D}"/>
+                <a16:creationId xmlns:a16="http://schemas.microsoft.com/office/drawing/2014/main" id="{584DE7AF-F976-4782-915F-99A51EAC07FB}"/>
               </a:ext>
             </a:extLst>
           </p:cNvPr>
@@ -2969,7 +2969,7 @@
     </p:spTree>
     <p:extLst>
       <p:ext uri="{BB962C8B-B14F-4D97-AF65-F5344CB8AC3E}">
-        <p14:creationId xmlns:p14="http://schemas.microsoft.com/office/powerpoint/2010/main" val="916365803"/>
+        <p14:creationId xmlns:p14="http://schemas.microsoft.com/office/powerpoint/2010/main" val="789895284"/>
       </p:ext>
     </p:extLst>
   </p:cSld>
@@ -3000,7 +3000,7 @@
           <p:cNvPr id="24" name="">
             <a:extLst xmlns:a="http://schemas.openxmlformats.org/drawingml/2006/main">
               <a:ext uri="{FF2B5EF4-FFF2-40B4-BE49-F238E27FC236}">
-                <a16:creationId xmlns:a16="http://schemas.microsoft.com/office/drawing/2014/main" id="{D7535CEC-2D52-48AB-88F9-624F51EBBDAA}"/>
+                <a16:creationId xmlns:a16="http://schemas.microsoft.com/office/drawing/2014/main" id="{A21C51C1-9CA6-45B1-B38E-31CD4E7AF648}"/>
               </a:ext>
             </a:extLst>
           </p:cNvPr>
@@ -3050,7 +3050,7 @@
           <p:cNvPr id="2" name="">
             <a:extLst xmlns:a="http://schemas.openxmlformats.org/drawingml/2006/main">
               <a:ext uri="{FF2B5EF4-FFF2-40B4-BE49-F238E27FC236}">
-                <a16:creationId xmlns:a16="http://schemas.microsoft.com/office/drawing/2014/main" id="{EFEC9D70-59CF-4F10-A2E6-7F5466C38B60}"/>
+                <a16:creationId xmlns:a16="http://schemas.microsoft.com/office/drawing/2014/main" id="{A3EE63CD-5CCD-4D52-904A-08967EDE3A5D}"/>
               </a:ext>
             </a:extLst>
           </p:cNvPr>
@@ -3083,7 +3083,7 @@
           <p:cNvPr id="3" name="">
             <a:extLst xmlns:a="http://schemas.openxmlformats.org/drawingml/2006/main">
               <a:ext uri="{FF2B5EF4-FFF2-40B4-BE49-F238E27FC236}">
-                <a16:creationId xmlns:a16="http://schemas.microsoft.com/office/drawing/2014/main" id="{8D3EA725-5B8D-4A0F-A6EE-B8C44B10892C}"/>
+                <a16:creationId xmlns:a16="http://schemas.microsoft.com/office/drawing/2014/main" id="{87C514FA-6B7F-4A6F-84F7-0BC6FC7F1814}"/>
               </a:ext>
             </a:extLst>
           </p:cNvPr>
@@ -3116,7 +3116,7 @@
           <p:cNvPr id="4" name="">
             <a:extLst xmlns:a="http://schemas.openxmlformats.org/drawingml/2006/main">
               <a:ext uri="{FF2B5EF4-FFF2-40B4-BE49-F238E27FC236}">
-                <a16:creationId xmlns:a16="http://schemas.microsoft.com/office/drawing/2014/main" id="{BC578356-5F76-4CCB-BA2E-20B1943A8BAE}"/>
+                <a16:creationId xmlns:a16="http://schemas.microsoft.com/office/drawing/2014/main" id="{7C9B7023-CD16-43BC-95FA-0299382C68A1}"/>
               </a:ext>
             </a:extLst>
           </p:cNvPr>
@@ -3166,7 +3166,7 @@
           <p:cNvPr id="5" name="">
             <a:extLst xmlns:a="http://schemas.openxmlformats.org/drawingml/2006/main">
               <a:ext uri="{FF2B5EF4-FFF2-40B4-BE49-F238E27FC236}">
-                <a16:creationId xmlns:a16="http://schemas.microsoft.com/office/drawing/2014/main" id="{13D9597D-E0F2-44F8-A958-A1CF7F4F1E94}"/>
+                <a16:creationId xmlns:a16="http://schemas.microsoft.com/office/drawing/2014/main" id="{ED0B1303-A643-4153-9FF9-B1C180CF743D}"/>
               </a:ext>
             </a:extLst>
           </p:cNvPr>
@@ -3216,7 +3216,7 @@
           <p:cNvPr id="6" name="">
             <a:extLst xmlns:a="http://schemas.openxmlformats.org/drawingml/2006/main">
               <a:ext uri="{FF2B5EF4-FFF2-40B4-BE49-F238E27FC236}">
-                <a16:creationId xmlns:a16="http://schemas.microsoft.com/office/drawing/2014/main" id="{79D61BA9-46DC-4D3F-8BC5-F1E45BB00C4E}"/>
+                <a16:creationId xmlns:a16="http://schemas.microsoft.com/office/drawing/2014/main" id="{496CD10E-CE95-4824-85FB-756700FA0A13}"/>
               </a:ext>
             </a:extLst>
           </p:cNvPr>
@@ -3249,7 +3249,7 @@
           <p:cNvPr id="7" name="">
             <a:extLst xmlns:a="http://schemas.openxmlformats.org/drawingml/2006/main">
               <a:ext uri="{FF2B5EF4-FFF2-40B4-BE49-F238E27FC236}">
-                <a16:creationId xmlns:a16="http://schemas.microsoft.com/office/drawing/2014/main" id="{80D014CA-B2BB-41FC-A04A-20DDD33EE7E4}"/>
+                <a16:creationId xmlns:a16="http://schemas.microsoft.com/office/drawing/2014/main" id="{38D12496-32F5-4BB5-AE77-72C5919C2CCB}"/>
               </a:ext>
             </a:extLst>
           </p:cNvPr>
@@ -3299,7 +3299,7 @@
           <p:cNvPr id="8" name="">
             <a:extLst xmlns:a="http://schemas.openxmlformats.org/drawingml/2006/main">
               <a:ext uri="{FF2B5EF4-FFF2-40B4-BE49-F238E27FC236}">
-                <a16:creationId xmlns:a16="http://schemas.microsoft.com/office/drawing/2014/main" id="{6F7B7F5B-E8E1-48DE-9240-ABC92E63D12D}"/>
+                <a16:creationId xmlns:a16="http://schemas.microsoft.com/office/drawing/2014/main" id="{84708949-ACC3-4325-895F-1104DA835F93}"/>
               </a:ext>
             </a:extLst>
           </p:cNvPr>
@@ -3349,7 +3349,7 @@
           <p:cNvPr id="9" name="">
             <a:extLst xmlns:a="http://schemas.openxmlformats.org/drawingml/2006/main">
               <a:ext uri="{FF2B5EF4-FFF2-40B4-BE49-F238E27FC236}">
-                <a16:creationId xmlns:a16="http://schemas.microsoft.com/office/drawing/2014/main" id="{F5E8971F-440E-4F52-9926-210C93839184}"/>
+                <a16:creationId xmlns:a16="http://schemas.microsoft.com/office/drawing/2014/main" id="{AF93C45D-6372-4BD6-81F3-F822258D5ADA}"/>
               </a:ext>
             </a:extLst>
           </p:cNvPr>
@@ -3382,7 +3382,7 @@
           <p:cNvPr id="10" name="">
             <a:extLst xmlns:a="http://schemas.openxmlformats.org/drawingml/2006/main">
               <a:ext uri="{FF2B5EF4-FFF2-40B4-BE49-F238E27FC236}">
-                <a16:creationId xmlns:a16="http://schemas.microsoft.com/office/drawing/2014/main" id="{2C2EDC75-5C72-4CDA-9E70-7E0465D9F832}"/>
+                <a16:creationId xmlns:a16="http://schemas.microsoft.com/office/drawing/2014/main" id="{61201B7D-7DE2-4F76-BB53-1ED69BBF7AAC}"/>
               </a:ext>
             </a:extLst>
           </p:cNvPr>
@@ -3432,7 +3432,7 @@
           <p:cNvPr id="11" name="">
             <a:extLst xmlns:a="http://schemas.openxmlformats.org/drawingml/2006/main">
               <a:ext uri="{FF2B5EF4-FFF2-40B4-BE49-F238E27FC236}">
-                <a16:creationId xmlns:a16="http://schemas.microsoft.com/office/drawing/2014/main" id="{36A6E696-2770-4860-A40D-6F4DDDA0AE63}"/>
+                <a16:creationId xmlns:a16="http://schemas.microsoft.com/office/drawing/2014/main" id="{F7169457-EEB2-4A8E-AFE0-47FA0CA7CA21}"/>
               </a:ext>
             </a:extLst>
           </p:cNvPr>
@@ -3482,7 +3482,7 @@
           <p:cNvPr id="12" name="">
             <a:extLst xmlns:a="http://schemas.openxmlformats.org/drawingml/2006/main">
               <a:ext uri="{FF2B5EF4-FFF2-40B4-BE49-F238E27FC236}">
-                <a16:creationId xmlns:a16="http://schemas.microsoft.com/office/drawing/2014/main" id="{AC9CD5E4-B3DF-46A4-9A72-C8C31D8D144E}"/>
+                <a16:creationId xmlns:a16="http://schemas.microsoft.com/office/drawing/2014/main" id="{696DB737-E5F7-4336-9F5E-8AA57F0522BB}"/>
               </a:ext>
             </a:extLst>
           </p:cNvPr>
@@ -3515,7 +3515,7 @@
           <p:cNvPr id="13" name="">
             <a:extLst xmlns:a="http://schemas.openxmlformats.org/drawingml/2006/main">
               <a:ext uri="{FF2B5EF4-FFF2-40B4-BE49-F238E27FC236}">
-                <a16:creationId xmlns:a16="http://schemas.microsoft.com/office/drawing/2014/main" id="{48928C2F-A138-4959-90BD-1CA2869EA27C}"/>
+                <a16:creationId xmlns:a16="http://schemas.microsoft.com/office/drawing/2014/main" id="{02DD3DF8-AF78-412A-9CC9-BA4D4DDB5980}"/>
               </a:ext>
             </a:extLst>
           </p:cNvPr>
@@ -3565,7 +3565,7 @@
           <p:cNvPr id="14" name="">
             <a:extLst xmlns:a="http://schemas.openxmlformats.org/drawingml/2006/main">
               <a:ext uri="{FF2B5EF4-FFF2-40B4-BE49-F238E27FC236}">
-                <a16:creationId xmlns:a16="http://schemas.microsoft.com/office/drawing/2014/main" id="{2EBCDC3E-4498-4E47-BFBD-A16524EFD20B}"/>
+                <a16:creationId xmlns:a16="http://schemas.microsoft.com/office/drawing/2014/main" id="{9EA3AED1-BD6B-4489-BEFE-70105EF6E4D6}"/>
               </a:ext>
             </a:extLst>
           </p:cNvPr>
@@ -3615,7 +3615,7 @@
           <p:cNvPr id="15" name="">
             <a:extLst xmlns:a="http://schemas.openxmlformats.org/drawingml/2006/main">
               <a:ext uri="{FF2B5EF4-FFF2-40B4-BE49-F238E27FC236}">
-                <a16:creationId xmlns:a16="http://schemas.microsoft.com/office/drawing/2014/main" id="{D1645EC8-111B-4C92-9831-191EAB72C6AF}"/>
+                <a16:creationId xmlns:a16="http://schemas.microsoft.com/office/drawing/2014/main" id="{B69304F6-B22C-4896-B7A3-D666E9DA8AD4}"/>
               </a:ext>
             </a:extLst>
           </p:cNvPr>
@@ -3648,7 +3648,7 @@
           <p:cNvPr id="16" name="">
             <a:extLst xmlns:a="http://schemas.openxmlformats.org/drawingml/2006/main">
               <a:ext uri="{FF2B5EF4-FFF2-40B4-BE49-F238E27FC236}">
-                <a16:creationId xmlns:a16="http://schemas.microsoft.com/office/drawing/2014/main" id="{604FDCBB-6C65-4A76-B1D8-10BC752DDF06}"/>
+                <a16:creationId xmlns:a16="http://schemas.microsoft.com/office/drawing/2014/main" id="{30CB720B-2494-4A41-81D4-35EA660588E5}"/>
               </a:ext>
             </a:extLst>
           </p:cNvPr>
@@ -3698,7 +3698,7 @@
           <p:cNvPr id="17" name="">
             <a:extLst xmlns:a="http://schemas.openxmlformats.org/drawingml/2006/main">
               <a:ext uri="{FF2B5EF4-FFF2-40B4-BE49-F238E27FC236}">
-                <a16:creationId xmlns:a16="http://schemas.microsoft.com/office/drawing/2014/main" id="{4DF903F3-208A-4D4D-836F-A7F4E5F2DEF8}"/>
+                <a16:creationId xmlns:a16="http://schemas.microsoft.com/office/drawing/2014/main" id="{D01C2CB8-B3AF-420D-A98A-93A1341DF166}"/>
               </a:ext>
             </a:extLst>
           </p:cNvPr>
@@ -3731,7 +3731,7 @@
           <p:cNvPr id="18" name="">
             <a:extLst xmlns:a="http://schemas.openxmlformats.org/drawingml/2006/main">
               <a:ext uri="{FF2B5EF4-FFF2-40B4-BE49-F238E27FC236}">
-                <a16:creationId xmlns:a16="http://schemas.microsoft.com/office/drawing/2014/main" id="{00AE56A1-6F39-471D-AF91-CF1C1C4E9D50}"/>
+                <a16:creationId xmlns:a16="http://schemas.microsoft.com/office/drawing/2014/main" id="{65642AC6-E8D9-4060-91FA-2F60F51A78C2}"/>
               </a:ext>
             </a:extLst>
           </p:cNvPr>
@@ -3781,7 +3781,7 @@
           <p:cNvPr id="19" name="">
             <a:extLst xmlns:a="http://schemas.openxmlformats.org/drawingml/2006/main">
               <a:ext uri="{FF2B5EF4-FFF2-40B4-BE49-F238E27FC236}">
-                <a16:creationId xmlns:a16="http://schemas.microsoft.com/office/drawing/2014/main" id="{7B189B54-D226-4F4D-9BA4-6EF8D50F70F7}"/>
+                <a16:creationId xmlns:a16="http://schemas.microsoft.com/office/drawing/2014/main" id="{64EE8363-13BA-4071-AFC3-AE4502FA9B3C}"/>
               </a:ext>
             </a:extLst>
           </p:cNvPr>
@@ -3814,7 +3814,7 @@
           <p:cNvPr id="20" name="">
             <a:extLst xmlns:a="http://schemas.openxmlformats.org/drawingml/2006/main">
               <a:ext uri="{FF2B5EF4-FFF2-40B4-BE49-F238E27FC236}">
-                <a16:creationId xmlns:a16="http://schemas.microsoft.com/office/drawing/2014/main" id="{D3949C2D-783A-45C2-AEBA-5BE7E521BF09}"/>
+                <a16:creationId xmlns:a16="http://schemas.microsoft.com/office/drawing/2014/main" id="{B023FBB1-5E51-4632-A07C-D70FAC176764}"/>
               </a:ext>
             </a:extLst>
           </p:cNvPr>
@@ -3864,7 +3864,7 @@
           <p:cNvPr id="21" name="">
             <a:extLst xmlns:a="http://schemas.openxmlformats.org/drawingml/2006/main">
               <a:ext uri="{FF2B5EF4-FFF2-40B4-BE49-F238E27FC236}">
-                <a16:creationId xmlns:a16="http://schemas.microsoft.com/office/drawing/2014/main" id="{A09BC1E8-5D20-44E5-BF34-01189347E993}"/>
+                <a16:creationId xmlns:a16="http://schemas.microsoft.com/office/drawing/2014/main" id="{28A4E316-5FB4-466D-98D1-9EF84F61643C}"/>
               </a:ext>
             </a:extLst>
           </p:cNvPr>
@@ -3897,7 +3897,7 @@
           <p:cNvPr id="22" name="">
             <a:extLst xmlns:a="http://schemas.openxmlformats.org/drawingml/2006/main">
               <a:ext uri="{FF2B5EF4-FFF2-40B4-BE49-F238E27FC236}">
-                <a16:creationId xmlns:a16="http://schemas.microsoft.com/office/drawing/2014/main" id="{C41F0A92-54E6-4A72-B883-252804F86998}"/>
+                <a16:creationId xmlns:a16="http://schemas.microsoft.com/office/drawing/2014/main" id="{77FFA02F-D575-4F49-8E3D-BF188DD51E7D}"/>
               </a:ext>
             </a:extLst>
           </p:cNvPr>
@@ -3947,7 +3947,7 @@
           <p:cNvPr id="23" name="">
             <a:extLst xmlns:a="http://schemas.openxmlformats.org/drawingml/2006/main">
               <a:ext uri="{FF2B5EF4-FFF2-40B4-BE49-F238E27FC236}">
-                <a16:creationId xmlns:a16="http://schemas.microsoft.com/office/drawing/2014/main" id="{566BDC98-7EAD-421A-A2EA-F4203A6A2A09}"/>
+                <a16:creationId xmlns:a16="http://schemas.microsoft.com/office/drawing/2014/main" id="{95C07E98-7ADE-4EC7-A9B7-7C0B65C14B24}"/>
               </a:ext>
             </a:extLst>
           </p:cNvPr>
@@ -3995,7 +3995,7 @@
     </p:spTree>
     <p:extLst>
       <p:ext uri="{BB962C8B-B14F-4D97-AF65-F5344CB8AC3E}">
-        <p14:creationId xmlns:p14="http://schemas.microsoft.com/office/powerpoint/2010/main" val="527387510"/>
+        <p14:creationId xmlns:p14="http://schemas.microsoft.com/office/powerpoint/2010/main" val="1818866405"/>
       </p:ext>
     </p:extLst>
   </p:cSld>
@@ -4026,7 +4026,7 @@
           <p:cNvPr id="20" name="">
             <a:extLst xmlns:a="http://schemas.openxmlformats.org/drawingml/2006/main">
               <a:ext uri="{FF2B5EF4-FFF2-40B4-BE49-F238E27FC236}">
-                <a16:creationId xmlns:a16="http://schemas.microsoft.com/office/drawing/2014/main" id="{87283C8B-4122-4E1C-A59E-0E67834AA466}"/>
+                <a16:creationId xmlns:a16="http://schemas.microsoft.com/office/drawing/2014/main" id="{11F32A42-5E70-4219-9E2F-6D4144BB18A6}"/>
               </a:ext>
             </a:extLst>
           </p:cNvPr>
@@ -4076,7 +4076,7 @@
           <p:cNvPr id="2" name="">
             <a:extLst xmlns:a="http://schemas.openxmlformats.org/drawingml/2006/main">
               <a:ext uri="{FF2B5EF4-FFF2-40B4-BE49-F238E27FC236}">
-                <a16:creationId xmlns:a16="http://schemas.microsoft.com/office/drawing/2014/main" id="{401CDAF8-D92E-4593-8224-EC9A596FA3AD}"/>
+                <a16:creationId xmlns:a16="http://schemas.microsoft.com/office/drawing/2014/main" id="{49B0D284-77AF-4784-9752-ABBDE638067E}"/>
               </a:ext>
             </a:extLst>
           </p:cNvPr>
@@ -4109,7 +4109,7 @@
           <p:cNvPr id="3" name="">
             <a:extLst xmlns:a="http://schemas.openxmlformats.org/drawingml/2006/main">
               <a:ext uri="{FF2B5EF4-FFF2-40B4-BE49-F238E27FC236}">
-                <a16:creationId xmlns:a16="http://schemas.microsoft.com/office/drawing/2014/main" id="{CBB8A3E6-DC55-46E6-9D07-24036A459FA3}"/>
+                <a16:creationId xmlns:a16="http://schemas.microsoft.com/office/drawing/2014/main" id="{9E4B0D2B-407E-45FE-BB05-DB3370F3EC5F}"/>
               </a:ext>
             </a:extLst>
           </p:cNvPr>
@@ -4142,7 +4142,7 @@
           <p:cNvPr id="4" name="">
             <a:extLst xmlns:a="http://schemas.openxmlformats.org/drawingml/2006/main">
               <a:ext uri="{FF2B5EF4-FFF2-40B4-BE49-F238E27FC236}">
-                <a16:creationId xmlns:a16="http://schemas.microsoft.com/office/drawing/2014/main" id="{4DBD9045-4A31-4BDC-B516-551B469DCC84}"/>
+                <a16:creationId xmlns:a16="http://schemas.microsoft.com/office/drawing/2014/main" id="{9D75BCAF-DE00-483D-82F2-27DE6BDFC709}"/>
               </a:ext>
             </a:extLst>
           </p:cNvPr>
@@ -4192,7 +4192,7 @@
           <p:cNvPr id="5" name="">
             <a:extLst xmlns:a="http://schemas.openxmlformats.org/drawingml/2006/main">
               <a:ext uri="{FF2B5EF4-FFF2-40B4-BE49-F238E27FC236}">
-                <a16:creationId xmlns:a16="http://schemas.microsoft.com/office/drawing/2014/main" id="{CD86B5B8-2673-426B-8D23-561EF55DA64D}"/>
+                <a16:creationId xmlns:a16="http://schemas.microsoft.com/office/drawing/2014/main" id="{88D69512-5C76-4D83-B505-A5717EA5F2A4}"/>
               </a:ext>
             </a:extLst>
           </p:cNvPr>
@@ -4242,7 +4242,7 @@
           <p:cNvPr id="6" name="">
             <a:extLst xmlns:a="http://schemas.openxmlformats.org/drawingml/2006/main">
               <a:ext uri="{FF2B5EF4-FFF2-40B4-BE49-F238E27FC236}">
-                <a16:creationId xmlns:a16="http://schemas.microsoft.com/office/drawing/2014/main" id="{012D2F27-AD18-4AC9-945F-1CE2001F090F}"/>
+                <a16:creationId xmlns:a16="http://schemas.microsoft.com/office/drawing/2014/main" id="{133FBE9E-19C8-4FC7-AA75-0D85960D8006}"/>
               </a:ext>
             </a:extLst>
           </p:cNvPr>
@@ -4292,7 +4292,7 @@
           <p:cNvPr id="7" name="">
             <a:extLst xmlns:a="http://schemas.openxmlformats.org/drawingml/2006/main">
               <a:ext uri="{FF2B5EF4-FFF2-40B4-BE49-F238E27FC236}">
-                <a16:creationId xmlns:a16="http://schemas.microsoft.com/office/drawing/2014/main" id="{0B981AD6-E7F6-4EF2-B8D3-D0EFA5112925}"/>
+                <a16:creationId xmlns:a16="http://schemas.microsoft.com/office/drawing/2014/main" id="{80858982-1E65-46DC-8620-D986630B0814}"/>
               </a:ext>
             </a:extLst>
           </p:cNvPr>
@@ -4325,7 +4325,7 @@
           <p:cNvPr id="8" name="">
             <a:extLst xmlns:a="http://schemas.openxmlformats.org/drawingml/2006/main">
               <a:ext uri="{FF2B5EF4-FFF2-40B4-BE49-F238E27FC236}">
-                <a16:creationId xmlns:a16="http://schemas.microsoft.com/office/drawing/2014/main" id="{F7A93FC7-429B-4016-9B87-52DD8DCE096F}"/>
+                <a16:creationId xmlns:a16="http://schemas.microsoft.com/office/drawing/2014/main" id="{70CBB39E-E8F7-47CB-B800-71453D84AC8A}"/>
               </a:ext>
             </a:extLst>
           </p:cNvPr>
@@ -4375,7 +4375,7 @@
           <p:cNvPr id="9" name="">
             <a:extLst xmlns:a="http://schemas.openxmlformats.org/drawingml/2006/main">
               <a:ext uri="{FF2B5EF4-FFF2-40B4-BE49-F238E27FC236}">
-                <a16:creationId xmlns:a16="http://schemas.microsoft.com/office/drawing/2014/main" id="{D93714A9-9B46-4911-BC33-4A095497EE93}"/>
+                <a16:creationId xmlns:a16="http://schemas.microsoft.com/office/drawing/2014/main" id="{AFBB4C30-AA7B-412D-AC51-1B33D39829CC}"/>
               </a:ext>
             </a:extLst>
           </p:cNvPr>
@@ -4425,7 +4425,7 @@
           <p:cNvPr id="10" name="">
             <a:extLst xmlns:a="http://schemas.openxmlformats.org/drawingml/2006/main">
               <a:ext uri="{FF2B5EF4-FFF2-40B4-BE49-F238E27FC236}">
-                <a16:creationId xmlns:a16="http://schemas.microsoft.com/office/drawing/2014/main" id="{CAE5313C-EBBE-4C8F-84C0-6A2B0F440CA9}"/>
+                <a16:creationId xmlns:a16="http://schemas.microsoft.com/office/drawing/2014/main" id="{0CFFC08D-18F3-49CA-A37F-DC7556FBB77D}"/>
               </a:ext>
             </a:extLst>
           </p:cNvPr>
@@ -4475,7 +4475,7 @@
           <p:cNvPr id="11" name="">
             <a:extLst xmlns:a="http://schemas.openxmlformats.org/drawingml/2006/main">
               <a:ext uri="{FF2B5EF4-FFF2-40B4-BE49-F238E27FC236}">
-                <a16:creationId xmlns:a16="http://schemas.microsoft.com/office/drawing/2014/main" id="{4C44F5C1-AC37-4512-B78B-2BA9A0268DAC}"/>
+                <a16:creationId xmlns:a16="http://schemas.microsoft.com/office/drawing/2014/main" id="{C78D8932-86BB-4C01-897F-9B02933D1760}"/>
               </a:ext>
             </a:extLst>
           </p:cNvPr>
@@ -4508,7 +4508,7 @@
           <p:cNvPr id="12" name="">
             <a:extLst xmlns:a="http://schemas.openxmlformats.org/drawingml/2006/main">
               <a:ext uri="{FF2B5EF4-FFF2-40B4-BE49-F238E27FC236}">
-                <a16:creationId xmlns:a16="http://schemas.microsoft.com/office/drawing/2014/main" id="{030137EE-7A98-484F-A47D-30B92E332F43}"/>
+                <a16:creationId xmlns:a16="http://schemas.microsoft.com/office/drawing/2014/main" id="{5709D029-81A1-499C-970D-A92503F33544}"/>
               </a:ext>
             </a:extLst>
           </p:cNvPr>
@@ -4558,7 +4558,7 @@
           <p:cNvPr id="13" name="">
             <a:extLst xmlns:a="http://schemas.openxmlformats.org/drawingml/2006/main">
               <a:ext uri="{FF2B5EF4-FFF2-40B4-BE49-F238E27FC236}">
-                <a16:creationId xmlns:a16="http://schemas.microsoft.com/office/drawing/2014/main" id="{4362B217-DC1B-4235-99BB-4365DFC9AA13}"/>
+                <a16:creationId xmlns:a16="http://schemas.microsoft.com/office/drawing/2014/main" id="{20CC648F-60B0-4279-B0E5-7D5F9222F872}"/>
               </a:ext>
             </a:extLst>
           </p:cNvPr>
@@ -4608,7 +4608,7 @@
           <p:cNvPr id="14" name="">
             <a:extLst xmlns:a="http://schemas.openxmlformats.org/drawingml/2006/main">
               <a:ext uri="{FF2B5EF4-FFF2-40B4-BE49-F238E27FC236}">
-                <a16:creationId xmlns:a16="http://schemas.microsoft.com/office/drawing/2014/main" id="{A39AD4E8-70D0-48AF-9F56-8B9A9DFFFA44}"/>
+                <a16:creationId xmlns:a16="http://schemas.microsoft.com/office/drawing/2014/main" id="{F4AC5EA3-F91F-4C62-9F19-FFD79CB911B7}"/>
               </a:ext>
             </a:extLst>
           </p:cNvPr>
@@ -4658,7 +4658,7 @@
           <p:cNvPr id="15" name="">
             <a:extLst xmlns:a="http://schemas.openxmlformats.org/drawingml/2006/main">
               <a:ext uri="{FF2B5EF4-FFF2-40B4-BE49-F238E27FC236}">
-                <a16:creationId xmlns:a16="http://schemas.microsoft.com/office/drawing/2014/main" id="{2ABE84B2-D8B6-48AA-8AAA-5B81F4AA8B14}"/>
+                <a16:creationId xmlns:a16="http://schemas.microsoft.com/office/drawing/2014/main" id="{8739E202-9CEF-4875-A985-FDA6CE6883D3}"/>
               </a:ext>
             </a:extLst>
           </p:cNvPr>
@@ -4691,7 +4691,7 @@
           <p:cNvPr id="16" name="">
             <a:extLst xmlns:a="http://schemas.openxmlformats.org/drawingml/2006/main">
               <a:ext uri="{FF2B5EF4-FFF2-40B4-BE49-F238E27FC236}">
-                <a16:creationId xmlns:a16="http://schemas.microsoft.com/office/drawing/2014/main" id="{BE14AA09-13C0-485E-A115-D5BF5DAB397D}"/>
+                <a16:creationId xmlns:a16="http://schemas.microsoft.com/office/drawing/2014/main" id="{E09C3455-FB20-4EAE-8E98-2EA204279D70}"/>
               </a:ext>
             </a:extLst>
           </p:cNvPr>
@@ -4741,7 +4741,7 @@
           <p:cNvPr id="17" name="">
             <a:extLst xmlns:a="http://schemas.openxmlformats.org/drawingml/2006/main">
               <a:ext uri="{FF2B5EF4-FFF2-40B4-BE49-F238E27FC236}">
-                <a16:creationId xmlns:a16="http://schemas.microsoft.com/office/drawing/2014/main" id="{7C67C2F1-1D60-4D4F-823F-EA1AFC67F95C}"/>
+                <a16:creationId xmlns:a16="http://schemas.microsoft.com/office/drawing/2014/main" id="{8B0C8934-FC27-41F9-919E-37129F14CB33}"/>
               </a:ext>
             </a:extLst>
           </p:cNvPr>
@@ -4791,7 +4791,7 @@
           <p:cNvPr id="18" name="">
             <a:extLst xmlns:a="http://schemas.openxmlformats.org/drawingml/2006/main">
               <a:ext uri="{FF2B5EF4-FFF2-40B4-BE49-F238E27FC236}">
-                <a16:creationId xmlns:a16="http://schemas.microsoft.com/office/drawing/2014/main" id="{03B75CF3-661B-45CA-B318-2F70879C949E}"/>
+                <a16:creationId xmlns:a16="http://schemas.microsoft.com/office/drawing/2014/main" id="{FC130A1D-A301-4C29-8AC9-75A406A0E05A}"/>
               </a:ext>
             </a:extLst>
           </p:cNvPr>
@@ -4841,7 +4841,7 @@
           <p:cNvPr id="19" name="">
             <a:extLst xmlns:a="http://schemas.openxmlformats.org/drawingml/2006/main">
               <a:ext uri="{FF2B5EF4-FFF2-40B4-BE49-F238E27FC236}">
-                <a16:creationId xmlns:a16="http://schemas.microsoft.com/office/drawing/2014/main" id="{C33351B3-B4DE-4694-ACDB-AA56C79A944F}"/>
+                <a16:creationId xmlns:a16="http://schemas.microsoft.com/office/drawing/2014/main" id="{633CD677-7FD3-45C6-A0AF-FAD9893AD08E}"/>
               </a:ext>
             </a:extLst>
           </p:cNvPr>
@@ -4889,7 +4889,7 @@
     </p:spTree>
     <p:extLst>
       <p:ext uri="{BB962C8B-B14F-4D97-AF65-F5344CB8AC3E}">
-        <p14:creationId xmlns:p14="http://schemas.microsoft.com/office/powerpoint/2010/main" val="2037174944"/>
+        <p14:creationId xmlns:p14="http://schemas.microsoft.com/office/powerpoint/2010/main" val="2106486652"/>
       </p:ext>
     </p:extLst>
   </p:cSld>
@@ -4920,7 +4920,7 @@
           <p:cNvPr id="15" name="">
             <a:extLst xmlns:a="http://schemas.openxmlformats.org/drawingml/2006/main">
               <a:ext uri="{FF2B5EF4-FFF2-40B4-BE49-F238E27FC236}">
-                <a16:creationId xmlns:a16="http://schemas.microsoft.com/office/drawing/2014/main" id="{777A4E6E-B1DC-4139-9D94-9AD5A682D462}"/>
+                <a16:creationId xmlns:a16="http://schemas.microsoft.com/office/drawing/2014/main" id="{E4AEB19E-387C-4BFB-A87C-CE2C2055AE59}"/>
               </a:ext>
             </a:extLst>
           </p:cNvPr>
@@ -4960,7 +4960,7 @@
                   <a:srgbClr val="111827"/>
                 </a:solidFill>
               </a:rPr>
-              <a:t>The prototype is already live and demo-ready</a:t>
+              <a:t>The final app is live and demo-ready</a:t>
             </a:r>
           </a:p>
         </p:txBody>
@@ -4970,7 +4970,7 @@
           <p:cNvPr id="2" name="">
             <a:extLst xmlns:a="http://schemas.openxmlformats.org/drawingml/2006/main">
               <a:ext uri="{FF2B5EF4-FFF2-40B4-BE49-F238E27FC236}">
-                <a16:creationId xmlns:a16="http://schemas.microsoft.com/office/drawing/2014/main" id="{49CEF1F6-616D-4C75-A397-DF28DA6A8D47}"/>
+                <a16:creationId xmlns:a16="http://schemas.microsoft.com/office/drawing/2014/main" id="{55FAA267-52C2-4DDA-9944-E921BEC79958}"/>
               </a:ext>
             </a:extLst>
           </p:cNvPr>
@@ -5003,7 +5003,7 @@
           <p:cNvPr id="3" name="">
             <a:extLst xmlns:a="http://schemas.openxmlformats.org/drawingml/2006/main">
               <a:ext uri="{FF2B5EF4-FFF2-40B4-BE49-F238E27FC236}">
-                <a16:creationId xmlns:a16="http://schemas.microsoft.com/office/drawing/2014/main" id="{D09CDCD3-E053-443F-96A6-3E8AC83C470D}"/>
+                <a16:creationId xmlns:a16="http://schemas.microsoft.com/office/drawing/2014/main" id="{8BEFCED1-FF77-4A91-B53C-632E6F833653}"/>
               </a:ext>
             </a:extLst>
           </p:cNvPr>
@@ -5036,7 +5036,7 @@
           <p:cNvPr id="4" name="">
             <a:extLst xmlns:a="http://schemas.openxmlformats.org/drawingml/2006/main">
               <a:ext uri="{FF2B5EF4-FFF2-40B4-BE49-F238E27FC236}">
-                <a16:creationId xmlns:a16="http://schemas.microsoft.com/office/drawing/2014/main" id="{F9C2489E-6794-44DD-AAFF-1C1AEA251496}"/>
+                <a16:creationId xmlns:a16="http://schemas.microsoft.com/office/drawing/2014/main" id="{E3ADB2CC-6305-46B0-B84F-27AC6DC92FE2}"/>
               </a:ext>
             </a:extLst>
           </p:cNvPr>
@@ -5086,7 +5086,7 @@
           <p:cNvPr id="5" name="">
             <a:extLst xmlns:a="http://schemas.openxmlformats.org/drawingml/2006/main">
               <a:ext uri="{FF2B5EF4-FFF2-40B4-BE49-F238E27FC236}">
-                <a16:creationId xmlns:a16="http://schemas.microsoft.com/office/drawing/2014/main" id="{7693F9C3-5539-4C3B-849C-9F81656E3D82}"/>
+                <a16:creationId xmlns:a16="http://schemas.microsoft.com/office/drawing/2014/main" id="{B51E795E-471E-4DAD-B45F-D2061E0E91DB}"/>
               </a:ext>
             </a:extLst>
           </p:cNvPr>
@@ -5119,7 +5119,7 @@
           <p:cNvPr id="6" name="">
             <a:extLst xmlns:a="http://schemas.openxmlformats.org/drawingml/2006/main">
               <a:ext uri="{FF2B5EF4-FFF2-40B4-BE49-F238E27FC236}">
-                <a16:creationId xmlns:a16="http://schemas.microsoft.com/office/drawing/2014/main" id="{5B05E2E4-7AE1-44D0-B28C-E18A11812835}"/>
+                <a16:creationId xmlns:a16="http://schemas.microsoft.com/office/drawing/2014/main" id="{5A0A3065-FA93-46D7-BFA1-9F8337830373}"/>
               </a:ext>
             </a:extLst>
           </p:cNvPr>
@@ -5169,7 +5169,7 @@
           <p:cNvPr id="7" name="">
             <a:extLst xmlns:a="http://schemas.openxmlformats.org/drawingml/2006/main">
               <a:ext uri="{FF2B5EF4-FFF2-40B4-BE49-F238E27FC236}">
-                <a16:creationId xmlns:a16="http://schemas.microsoft.com/office/drawing/2014/main" id="{57266763-3106-43C8-9F86-B26B9C7F3047}"/>
+                <a16:creationId xmlns:a16="http://schemas.microsoft.com/office/drawing/2014/main" id="{56AE9378-216C-4A45-83CD-CE1F8F9DDD4B}"/>
               </a:ext>
             </a:extLst>
           </p:cNvPr>
@@ -5202,7 +5202,7 @@
           <p:cNvPr id="8" name="">
             <a:extLst xmlns:a="http://schemas.openxmlformats.org/drawingml/2006/main">
               <a:ext uri="{FF2B5EF4-FFF2-40B4-BE49-F238E27FC236}">
-                <a16:creationId xmlns:a16="http://schemas.microsoft.com/office/drawing/2014/main" id="{E7C061AA-68F8-4F49-B379-356CC268EB81}"/>
+                <a16:creationId xmlns:a16="http://schemas.microsoft.com/office/drawing/2014/main" id="{494FE451-B702-4C94-BD75-9DD474FD973E}"/>
               </a:ext>
             </a:extLst>
           </p:cNvPr>
@@ -5252,7 +5252,7 @@
           <p:cNvPr id="9" name="">
             <a:extLst xmlns:a="http://schemas.openxmlformats.org/drawingml/2006/main">
               <a:ext uri="{FF2B5EF4-FFF2-40B4-BE49-F238E27FC236}">
-                <a16:creationId xmlns:a16="http://schemas.microsoft.com/office/drawing/2014/main" id="{D45BF6BF-E408-45A9-A1AE-FC88DF6AB592}"/>
+                <a16:creationId xmlns:a16="http://schemas.microsoft.com/office/drawing/2014/main" id="{F89AF325-C73D-4517-BF07-DE731DF3C427}"/>
               </a:ext>
             </a:extLst>
           </p:cNvPr>
@@ -5285,7 +5285,7 @@
           <p:cNvPr id="10" name="">
             <a:extLst xmlns:a="http://schemas.openxmlformats.org/drawingml/2006/main">
               <a:ext uri="{FF2B5EF4-FFF2-40B4-BE49-F238E27FC236}">
-                <a16:creationId xmlns:a16="http://schemas.microsoft.com/office/drawing/2014/main" id="{8E017484-3789-4B70-ADB6-4455774ED48F}"/>
+                <a16:creationId xmlns:a16="http://schemas.microsoft.com/office/drawing/2014/main" id="{730A51C4-ADC3-42DD-A035-C5D058B47933}"/>
               </a:ext>
             </a:extLst>
           </p:cNvPr>
@@ -5325,7 +5325,7 @@
                   <a:srgbClr val="111827"/>
                 </a:solidFill>
               </a:rPr>
-              <a:t>Attempt log, CSV export, and research-readiness panel.</a:t>
+              <a:t>Attempt log, CSV export, and trained vault model panel.</a:t>
             </a:r>
           </a:p>
         </p:txBody>
@@ -5335,7 +5335,7 @@
           <p:cNvPr id="11" name="">
             <a:extLst xmlns:a="http://schemas.openxmlformats.org/drawingml/2006/main">
               <a:ext uri="{FF2B5EF4-FFF2-40B4-BE49-F238E27FC236}">
-                <a16:creationId xmlns:a16="http://schemas.microsoft.com/office/drawing/2014/main" id="{F7F92E77-6160-491B-82BD-1CF70031FFD0}"/>
+                <a16:creationId xmlns:a16="http://schemas.microsoft.com/office/drawing/2014/main" id="{75C7C1D4-0E48-4C43-9463-84A44E077D85}"/>
               </a:ext>
             </a:extLst>
           </p:cNvPr>
@@ -5368,7 +5368,7 @@
           <p:cNvPr id="12" name="">
             <a:extLst xmlns:a="http://schemas.openxmlformats.org/drawingml/2006/main">
               <a:ext uri="{FF2B5EF4-FFF2-40B4-BE49-F238E27FC236}">
-                <a16:creationId xmlns:a16="http://schemas.microsoft.com/office/drawing/2014/main" id="{DA0F8CA3-9735-43D1-8BDA-181C3B0C6756}"/>
+                <a16:creationId xmlns:a16="http://schemas.microsoft.com/office/drawing/2014/main" id="{25DD2547-B65A-4D48-A957-C664C3F03EE2}"/>
               </a:ext>
             </a:extLst>
           </p:cNvPr>
@@ -5418,7 +5418,7 @@
           <p:cNvPr id="13" name="">
             <a:extLst xmlns:a="http://schemas.openxmlformats.org/drawingml/2006/main">
               <a:ext uri="{FF2B5EF4-FFF2-40B4-BE49-F238E27FC236}">
-                <a16:creationId xmlns:a16="http://schemas.microsoft.com/office/drawing/2014/main" id="{062A7853-1B17-466D-B4E2-1C3A35014CBA}"/>
+                <a16:creationId xmlns:a16="http://schemas.microsoft.com/office/drawing/2014/main" id="{6662402E-306C-4042-A2F6-37078D42CABB}"/>
               </a:ext>
             </a:extLst>
           </p:cNvPr>
@@ -5468,7 +5468,7 @@
           <p:cNvPr id="14" name="">
             <a:extLst xmlns:a="http://schemas.openxmlformats.org/drawingml/2006/main">
               <a:ext uri="{FF2B5EF4-FFF2-40B4-BE49-F238E27FC236}">
-                <a16:creationId xmlns:a16="http://schemas.microsoft.com/office/drawing/2014/main" id="{9445264F-C694-4750-82F7-E12C52EA6188}"/>
+                <a16:creationId xmlns:a16="http://schemas.microsoft.com/office/drawing/2014/main" id="{7ED69ADB-0932-48F4-8E3F-F27E4EC8AE95}"/>
               </a:ext>
             </a:extLst>
           </p:cNvPr>
@@ -5516,7 +5516,7 @@
     </p:spTree>
     <p:extLst>
       <p:ext uri="{BB962C8B-B14F-4D97-AF65-F5344CB8AC3E}">
-        <p14:creationId xmlns:p14="http://schemas.microsoft.com/office/powerpoint/2010/main" val="1948603427"/>
+        <p14:creationId xmlns:p14="http://schemas.microsoft.com/office/powerpoint/2010/main" val="331710980"/>
       </p:ext>
     </p:extLst>
   </p:cSld>
@@ -5547,7 +5547,7 @@
           <p:cNvPr id="14" name="">
             <a:extLst xmlns:a="http://schemas.openxmlformats.org/drawingml/2006/main">
               <a:ext uri="{FF2B5EF4-FFF2-40B4-BE49-F238E27FC236}">
-                <a16:creationId xmlns:a16="http://schemas.microsoft.com/office/drawing/2014/main" id="{7711C263-4CD3-4B85-8A9A-4C58E3316C73}"/>
+                <a16:creationId xmlns:a16="http://schemas.microsoft.com/office/drawing/2014/main" id="{73E189C0-6D50-44A8-8C6A-CCDEA1810D12}"/>
               </a:ext>
             </a:extLst>
           </p:cNvPr>
@@ -5587,7 +5587,7 @@
                   <a:srgbClr val="111827"/>
                 </a:solidFill>
               </a:rPr>
-              <a:t>Early result: the honest prototype is more valuable</a:t>
+              <a:t>Early result: honest AI feedback is more valuable</a:t>
             </a:r>
           </a:p>
         </p:txBody>
@@ -5597,7 +5597,7 @@
           <p:cNvPr id="2" name="">
             <a:extLst xmlns:a="http://schemas.openxmlformats.org/drawingml/2006/main">
               <a:ext uri="{FF2B5EF4-FFF2-40B4-BE49-F238E27FC236}">
-                <a16:creationId xmlns:a16="http://schemas.microsoft.com/office/drawing/2014/main" id="{3EA79498-36EC-4A32-8731-D1CAC2A32CD1}"/>
+                <a16:creationId xmlns:a16="http://schemas.microsoft.com/office/drawing/2014/main" id="{8912F1DA-26D4-4388-948E-F8AAFDDE6BC0}"/>
               </a:ext>
             </a:extLst>
           </p:cNvPr>
@@ -5630,7 +5630,7 @@
           <p:cNvPr id="3" name="">
             <a:extLst xmlns:a="http://schemas.openxmlformats.org/drawingml/2006/main">
               <a:ext uri="{FF2B5EF4-FFF2-40B4-BE49-F238E27FC236}">
-                <a16:creationId xmlns:a16="http://schemas.microsoft.com/office/drawing/2014/main" id="{A4AC9F92-6CC6-4D1E-B262-5D3E04200D44}"/>
+                <a16:creationId xmlns:a16="http://schemas.microsoft.com/office/drawing/2014/main" id="{74CAF136-FE37-49BD-99ED-90A8444FABD2}"/>
               </a:ext>
             </a:extLst>
           </p:cNvPr>
@@ -5680,7 +5680,7 @@
           <p:cNvPr id="4" name="">
             <a:extLst xmlns:a="http://schemas.openxmlformats.org/drawingml/2006/main">
               <a:ext uri="{FF2B5EF4-FFF2-40B4-BE49-F238E27FC236}">
-                <a16:creationId xmlns:a16="http://schemas.microsoft.com/office/drawing/2014/main" id="{188D22EE-F5F1-43C2-AC15-657FE4410429}"/>
+                <a16:creationId xmlns:a16="http://schemas.microsoft.com/office/drawing/2014/main" id="{27EAED95-7D6E-4371-8552-E06646465BD6}"/>
               </a:ext>
             </a:extLst>
           </p:cNvPr>
@@ -5713,7 +5713,7 @@
           <p:cNvPr id="5" name="">
             <a:extLst xmlns:a="http://schemas.openxmlformats.org/drawingml/2006/main">
               <a:ext uri="{FF2B5EF4-FFF2-40B4-BE49-F238E27FC236}">
-                <a16:creationId xmlns:a16="http://schemas.microsoft.com/office/drawing/2014/main" id="{940EBAAA-7EB9-42FD-AEC1-71E380746F17}"/>
+                <a16:creationId xmlns:a16="http://schemas.microsoft.com/office/drawing/2014/main" id="{12BB7D6D-D3A5-4081-AFA1-0EADE9113902}"/>
               </a:ext>
             </a:extLst>
           </p:cNvPr>
@@ -5763,7 +5763,7 @@
           <p:cNvPr id="6" name="">
             <a:extLst xmlns:a="http://schemas.openxmlformats.org/drawingml/2006/main">
               <a:ext uri="{FF2B5EF4-FFF2-40B4-BE49-F238E27FC236}">
-                <a16:creationId xmlns:a16="http://schemas.microsoft.com/office/drawing/2014/main" id="{CB9A1DDA-B31B-45CE-AB31-8A5FDD6203F1}"/>
+                <a16:creationId xmlns:a16="http://schemas.microsoft.com/office/drawing/2014/main" id="{F4D2C8FD-3F4D-4602-B1E2-45714199413C}"/>
               </a:ext>
             </a:extLst>
           </p:cNvPr>
@@ -5796,7 +5796,7 @@
           <p:cNvPr id="7" name="">
             <a:extLst xmlns:a="http://schemas.openxmlformats.org/drawingml/2006/main">
               <a:ext uri="{FF2B5EF4-FFF2-40B4-BE49-F238E27FC236}">
-                <a16:creationId xmlns:a16="http://schemas.microsoft.com/office/drawing/2014/main" id="{628E789A-0BB1-4218-8D48-6EE72105FE8E}"/>
+                <a16:creationId xmlns:a16="http://schemas.microsoft.com/office/drawing/2014/main" id="{A9557FAC-F1E7-4352-A946-DAD2F2749FF6}"/>
               </a:ext>
             </a:extLst>
           </p:cNvPr>
@@ -5846,7 +5846,7 @@
           <p:cNvPr id="8" name="">
             <a:extLst xmlns:a="http://schemas.openxmlformats.org/drawingml/2006/main">
               <a:ext uri="{FF2B5EF4-FFF2-40B4-BE49-F238E27FC236}">
-                <a16:creationId xmlns:a16="http://schemas.microsoft.com/office/drawing/2014/main" id="{F0BDC6EE-A432-450E-B12D-54F7630DACC4}"/>
+                <a16:creationId xmlns:a16="http://schemas.microsoft.com/office/drawing/2014/main" id="{7F4160A4-D26F-4657-B280-ABD05F74A5F7}"/>
               </a:ext>
             </a:extLst>
           </p:cNvPr>
@@ -5879,7 +5879,7 @@
           <p:cNvPr id="9" name="">
             <a:extLst xmlns:a="http://schemas.openxmlformats.org/drawingml/2006/main">
               <a:ext uri="{FF2B5EF4-FFF2-40B4-BE49-F238E27FC236}">
-                <a16:creationId xmlns:a16="http://schemas.microsoft.com/office/drawing/2014/main" id="{636EF26B-ED7F-4FE5-931F-D7BC9122D1F1}"/>
+                <a16:creationId xmlns:a16="http://schemas.microsoft.com/office/drawing/2014/main" id="{3FADB8F6-23AE-4B44-B600-FF8CCD2FFF23}"/>
               </a:ext>
             </a:extLst>
           </p:cNvPr>
@@ -5929,7 +5929,7 @@
           <p:cNvPr id="10" name="">
             <a:extLst xmlns:a="http://schemas.openxmlformats.org/drawingml/2006/main">
               <a:ext uri="{FF2B5EF4-FFF2-40B4-BE49-F238E27FC236}">
-                <a16:creationId xmlns:a16="http://schemas.microsoft.com/office/drawing/2014/main" id="{78B7B2FD-A12A-4E7E-BF62-D7B1D8E4D66D}"/>
+                <a16:creationId xmlns:a16="http://schemas.microsoft.com/office/drawing/2014/main" id="{F1E84D3B-24B7-4037-B1D3-7A4678C7B88E}"/>
               </a:ext>
             </a:extLst>
           </p:cNvPr>
@@ -5962,7 +5962,7 @@
           <p:cNvPr id="11" name="">
             <a:extLst xmlns:a="http://schemas.openxmlformats.org/drawingml/2006/main">
               <a:ext uri="{FF2B5EF4-FFF2-40B4-BE49-F238E27FC236}">
-                <a16:creationId xmlns:a16="http://schemas.microsoft.com/office/drawing/2014/main" id="{9426ADE7-2EB5-44BF-8D7A-835DFB0FCE2A}"/>
+                <a16:creationId xmlns:a16="http://schemas.microsoft.com/office/drawing/2014/main" id="{0E03716B-8E9D-489F-B15C-E034CE7BC427}"/>
               </a:ext>
             </a:extLst>
           </p:cNvPr>
@@ -6012,7 +6012,7 @@
           <p:cNvPr id="12" name="">
             <a:extLst xmlns:a="http://schemas.openxmlformats.org/drawingml/2006/main">
               <a:ext uri="{FF2B5EF4-FFF2-40B4-BE49-F238E27FC236}">
-                <a16:creationId xmlns:a16="http://schemas.microsoft.com/office/drawing/2014/main" id="{2E735F62-F484-4E75-B9EF-B413B491A74D}"/>
+                <a16:creationId xmlns:a16="http://schemas.microsoft.com/office/drawing/2014/main" id="{17165EF5-4D53-41CC-821B-59F37BD6F342}"/>
               </a:ext>
             </a:extLst>
           </p:cNvPr>
@@ -6052,7 +6052,7 @@
                   <a:srgbClr val="4B5563"/>
                 </a:solidFill>
               </a:rPr>
-              <a:t>Prototype principle</a:t>
+              <a:t>Model principle</a:t>
             </a:r>
           </a:p>
         </p:txBody>
@@ -6062,7 +6062,7 @@
           <p:cNvPr id="13" name="">
             <a:extLst xmlns:a="http://schemas.openxmlformats.org/drawingml/2006/main">
               <a:ext uri="{FF2B5EF4-FFF2-40B4-BE49-F238E27FC236}">
-                <a16:creationId xmlns:a16="http://schemas.microsoft.com/office/drawing/2014/main" id="{F133EC51-F745-4800-B740-CE9A9E471700}"/>
+                <a16:creationId xmlns:a16="http://schemas.microsoft.com/office/drawing/2014/main" id="{54F7696C-A49D-4027-9745-AE6E1349A853}"/>
               </a:ext>
             </a:extLst>
           </p:cNvPr>
@@ -6110,7 +6110,7 @@
     </p:spTree>
     <p:extLst>
       <p:ext uri="{BB962C8B-B14F-4D97-AF65-F5344CB8AC3E}">
-        <p14:creationId xmlns:p14="http://schemas.microsoft.com/office/powerpoint/2010/main" val="1390360510"/>
+        <p14:creationId xmlns:p14="http://schemas.microsoft.com/office/powerpoint/2010/main" val="1771196174"/>
       </p:ext>
     </p:extLst>
   </p:cSld>
@@ -6141,7 +6141,7 @@
           <p:cNvPr id="12" name="">
             <a:extLst xmlns:a="http://schemas.openxmlformats.org/drawingml/2006/main">
               <a:ext uri="{FF2B5EF4-FFF2-40B4-BE49-F238E27FC236}">
-                <a16:creationId xmlns:a16="http://schemas.microsoft.com/office/drawing/2014/main" id="{1371F2EB-09A3-4BC9-AEA7-C32B3A8E4289}"/>
+                <a16:creationId xmlns:a16="http://schemas.microsoft.com/office/drawing/2014/main" id="{2C976272-7E84-4840-9720-20A0849EC13B}"/>
               </a:ext>
             </a:extLst>
           </p:cNvPr>
@@ -6191,7 +6191,7 @@
           <p:cNvPr id="2" name="">
             <a:extLst xmlns:a="http://schemas.openxmlformats.org/drawingml/2006/main">
               <a:ext uri="{FF2B5EF4-FFF2-40B4-BE49-F238E27FC236}">
-                <a16:creationId xmlns:a16="http://schemas.microsoft.com/office/drawing/2014/main" id="{560B090E-0EC1-4E8F-B9C5-1830FE3AD03D}"/>
+                <a16:creationId xmlns:a16="http://schemas.microsoft.com/office/drawing/2014/main" id="{C36D3CAF-7A10-4440-8E6B-67D6B451C178}"/>
               </a:ext>
             </a:extLst>
           </p:cNvPr>
@@ -6224,7 +6224,7 @@
           <p:cNvPr id="3" name="">
             <a:extLst xmlns:a="http://schemas.openxmlformats.org/drawingml/2006/main">
               <a:ext uri="{FF2B5EF4-FFF2-40B4-BE49-F238E27FC236}">
-                <a16:creationId xmlns:a16="http://schemas.microsoft.com/office/drawing/2014/main" id="{5F374290-B8F3-40DE-91BB-35478BB4F128}"/>
+                <a16:creationId xmlns:a16="http://schemas.microsoft.com/office/drawing/2014/main" id="{6845B36F-DF95-4669-9EF8-CD8A86F53507}"/>
               </a:ext>
             </a:extLst>
           </p:cNvPr>
@@ -6257,7 +6257,7 @@
           <p:cNvPr id="4" name="">
             <a:extLst xmlns:a="http://schemas.openxmlformats.org/drawingml/2006/main">
               <a:ext uri="{FF2B5EF4-FFF2-40B4-BE49-F238E27FC236}">
-                <a16:creationId xmlns:a16="http://schemas.microsoft.com/office/drawing/2014/main" id="{EC0CB280-8686-432E-892A-A3C0FC78A574}"/>
+                <a16:creationId xmlns:a16="http://schemas.microsoft.com/office/drawing/2014/main" id="{10B48E66-DE29-4FA3-ABFB-CB855B097C12}"/>
               </a:ext>
             </a:extLst>
           </p:cNvPr>
@@ -6307,7 +6307,7 @@
           <p:cNvPr id="5" name="">
             <a:extLst xmlns:a="http://schemas.openxmlformats.org/drawingml/2006/main">
               <a:ext uri="{FF2B5EF4-FFF2-40B4-BE49-F238E27FC236}">
-                <a16:creationId xmlns:a16="http://schemas.microsoft.com/office/drawing/2014/main" id="{14A7B9D8-108E-4C3F-BD98-4166395AA103}"/>
+                <a16:creationId xmlns:a16="http://schemas.microsoft.com/office/drawing/2014/main" id="{C9C88439-58B0-4072-A004-AAF3EC21F454}"/>
               </a:ext>
             </a:extLst>
           </p:cNvPr>
@@ -6340,7 +6340,7 @@
           <p:cNvPr id="6" name="">
             <a:extLst xmlns:a="http://schemas.openxmlformats.org/drawingml/2006/main">
               <a:ext uri="{FF2B5EF4-FFF2-40B4-BE49-F238E27FC236}">
-                <a16:creationId xmlns:a16="http://schemas.microsoft.com/office/drawing/2014/main" id="{8D5069FE-C799-4DF0-8157-CC292E9D3C56}"/>
+                <a16:creationId xmlns:a16="http://schemas.microsoft.com/office/drawing/2014/main" id="{83426AC7-F8DF-4EA2-9352-69F67C94EFE7}"/>
               </a:ext>
             </a:extLst>
           </p:cNvPr>
@@ -6390,7 +6390,7 @@
           <p:cNvPr id="7" name="">
             <a:extLst xmlns:a="http://schemas.openxmlformats.org/drawingml/2006/main">
               <a:ext uri="{FF2B5EF4-FFF2-40B4-BE49-F238E27FC236}">
-                <a16:creationId xmlns:a16="http://schemas.microsoft.com/office/drawing/2014/main" id="{C6E64452-068C-4226-AD95-2A3348461D5E}"/>
+                <a16:creationId xmlns:a16="http://schemas.microsoft.com/office/drawing/2014/main" id="{9A8BADF7-A0A3-4F26-9721-A77147AAE23E}"/>
               </a:ext>
             </a:extLst>
           </p:cNvPr>
@@ -6423,7 +6423,7 @@
           <p:cNvPr id="8" name="">
             <a:extLst xmlns:a="http://schemas.openxmlformats.org/drawingml/2006/main">
               <a:ext uri="{FF2B5EF4-FFF2-40B4-BE49-F238E27FC236}">
-                <a16:creationId xmlns:a16="http://schemas.microsoft.com/office/drawing/2014/main" id="{CE93E9FC-CD58-451C-B07A-A6E949D33EDA}"/>
+                <a16:creationId xmlns:a16="http://schemas.microsoft.com/office/drawing/2014/main" id="{3685C066-7DC1-429D-A5C3-40A19E24CDE4}"/>
               </a:ext>
             </a:extLst>
           </p:cNvPr>
@@ -6473,7 +6473,7 @@
           <p:cNvPr id="9" name="">
             <a:extLst xmlns:a="http://schemas.openxmlformats.org/drawingml/2006/main">
               <a:ext uri="{FF2B5EF4-FFF2-40B4-BE49-F238E27FC236}">
-                <a16:creationId xmlns:a16="http://schemas.microsoft.com/office/drawing/2014/main" id="{693387B4-5FB6-4CBB-AC6A-0622991338A7}"/>
+                <a16:creationId xmlns:a16="http://schemas.microsoft.com/office/drawing/2014/main" id="{1464010E-BE5C-40C4-A88C-8D96A517ACAF}"/>
               </a:ext>
             </a:extLst>
           </p:cNvPr>
@@ -6506,7 +6506,7 @@
           <p:cNvPr id="10" name="">
             <a:extLst xmlns:a="http://schemas.openxmlformats.org/drawingml/2006/main">
               <a:ext uri="{FF2B5EF4-FFF2-40B4-BE49-F238E27FC236}">
-                <a16:creationId xmlns:a16="http://schemas.microsoft.com/office/drawing/2014/main" id="{349BDDED-EDA6-4A0C-8C6A-D29FFD11EA3E}"/>
+                <a16:creationId xmlns:a16="http://schemas.microsoft.com/office/drawing/2014/main" id="{262EA2E5-A98E-4343-81EF-788FB17B90F8}"/>
               </a:ext>
             </a:extLst>
           </p:cNvPr>
@@ -6556,7 +6556,7 @@
           <p:cNvPr id="11" name="">
             <a:extLst xmlns:a="http://schemas.openxmlformats.org/drawingml/2006/main">
               <a:ext uri="{FF2B5EF4-FFF2-40B4-BE49-F238E27FC236}">
-                <a16:creationId xmlns:a16="http://schemas.microsoft.com/office/drawing/2014/main" id="{25BC7FF7-2F47-42A7-B7E4-C2647A39FD28}"/>
+                <a16:creationId xmlns:a16="http://schemas.microsoft.com/office/drawing/2014/main" id="{C0FBCFAD-2B54-4D2B-B725-B2BA6FB37B29}"/>
               </a:ext>
             </a:extLst>
           </p:cNvPr>
@@ -6604,7 +6604,7 @@
     </p:spTree>
     <p:extLst>
       <p:ext uri="{BB962C8B-B14F-4D97-AF65-F5344CB8AC3E}">
-        <p14:creationId xmlns:p14="http://schemas.microsoft.com/office/powerpoint/2010/main" val="1321108431"/>
+        <p14:creationId xmlns:p14="http://schemas.microsoft.com/office/powerpoint/2010/main" val="1221285220"/>
       </p:ext>
     </p:extLst>
   </p:cSld>
@@ -6635,7 +6635,7 @@
           <p:cNvPr id="18" name="">
             <a:extLst xmlns:a="http://schemas.openxmlformats.org/drawingml/2006/main">
               <a:ext uri="{FF2B5EF4-FFF2-40B4-BE49-F238E27FC236}">
-                <a16:creationId xmlns:a16="http://schemas.microsoft.com/office/drawing/2014/main" id="{3877E69A-218A-4889-A6B0-58EA957BDCDB}"/>
+                <a16:creationId xmlns:a16="http://schemas.microsoft.com/office/drawing/2014/main" id="{A3A12944-EBC4-409F-A4EF-D2D9D9337821}"/>
               </a:ext>
             </a:extLst>
           </p:cNvPr>
@@ -6675,7 +6675,7 @@
                   <a:srgbClr val="111827"/>
                 </a:solidFill>
               </a:rPr>
-              <a:t>Next milestone: validate the model with real attempts</a:t>
+              <a:t>Next milestone: validate and improve the trained model</a:t>
             </a:r>
           </a:p>
         </p:txBody>
@@ -6685,7 +6685,7 @@
           <p:cNvPr id="2" name="">
             <a:extLst xmlns:a="http://schemas.openxmlformats.org/drawingml/2006/main">
               <a:ext uri="{FF2B5EF4-FFF2-40B4-BE49-F238E27FC236}">
-                <a16:creationId xmlns:a16="http://schemas.microsoft.com/office/drawing/2014/main" id="{9CDC932D-DCAA-4716-AABB-8B6612A0E766}"/>
+                <a16:creationId xmlns:a16="http://schemas.microsoft.com/office/drawing/2014/main" id="{5A4C4CB7-473D-4BD6-BF0B-AB8C8730E973}"/>
               </a:ext>
             </a:extLst>
           </p:cNvPr>
@@ -6718,7 +6718,7 @@
           <p:cNvPr id="3" name="">
             <a:extLst xmlns:a="http://schemas.openxmlformats.org/drawingml/2006/main">
               <a:ext uri="{FF2B5EF4-FFF2-40B4-BE49-F238E27FC236}">
-                <a16:creationId xmlns:a16="http://schemas.microsoft.com/office/drawing/2014/main" id="{9B7A221B-0D7D-4054-A4C1-EACE42767926}"/>
+                <a16:creationId xmlns:a16="http://schemas.microsoft.com/office/drawing/2014/main" id="{C34B020A-EB0A-46CE-972B-6F31363F6F3F}"/>
               </a:ext>
             </a:extLst>
           </p:cNvPr>
@@ -6751,7 +6751,7 @@
           <p:cNvPr id="4" name="">
             <a:extLst xmlns:a="http://schemas.openxmlformats.org/drawingml/2006/main">
               <a:ext uri="{FF2B5EF4-FFF2-40B4-BE49-F238E27FC236}">
-                <a16:creationId xmlns:a16="http://schemas.microsoft.com/office/drawing/2014/main" id="{3425D9F0-CBFC-4ECB-B37F-F7B6438D0EC2}"/>
+                <a16:creationId xmlns:a16="http://schemas.microsoft.com/office/drawing/2014/main" id="{8EEB2FFB-465E-4F46-8E0F-7D85428CB0A2}"/>
               </a:ext>
             </a:extLst>
           </p:cNvPr>
@@ -6801,7 +6801,7 @@
           <p:cNvPr id="5" name="">
             <a:extLst xmlns:a="http://schemas.openxmlformats.org/drawingml/2006/main">
               <a:ext uri="{FF2B5EF4-FFF2-40B4-BE49-F238E27FC236}">
-                <a16:creationId xmlns:a16="http://schemas.microsoft.com/office/drawing/2014/main" id="{933422D0-6C89-4289-91B4-6DF16F29A19B}"/>
+                <a16:creationId xmlns:a16="http://schemas.microsoft.com/office/drawing/2014/main" id="{41AF2D8B-B632-4D87-9A93-D5E3A7AC1268}"/>
               </a:ext>
             </a:extLst>
           </p:cNvPr>
@@ -6834,7 +6834,7 @@
           <p:cNvPr id="6" name="">
             <a:extLst xmlns:a="http://schemas.openxmlformats.org/drawingml/2006/main">
               <a:ext uri="{FF2B5EF4-FFF2-40B4-BE49-F238E27FC236}">
-                <a16:creationId xmlns:a16="http://schemas.microsoft.com/office/drawing/2014/main" id="{C4A5DB4C-2FFD-431E-81C9-A332D3A7EC20}"/>
+                <a16:creationId xmlns:a16="http://schemas.microsoft.com/office/drawing/2014/main" id="{CE57FF8B-3A20-4199-AE15-F1B8461B950B}"/>
               </a:ext>
             </a:extLst>
           </p:cNvPr>
@@ -6874,7 +6874,7 @@
                   <a:srgbClr val="111827"/>
                 </a:solidFill>
               </a:rPr>
-              <a:t>Train logistic regression on exported CSV data.</a:t>
+              <a:t>Test logistic regression accuracy on held-out attempts.</a:t>
             </a:r>
           </a:p>
         </p:txBody>
@@ -6884,7 +6884,7 @@
           <p:cNvPr id="7" name="">
             <a:extLst xmlns:a="http://schemas.openxmlformats.org/drawingml/2006/main">
               <a:ext uri="{FF2B5EF4-FFF2-40B4-BE49-F238E27FC236}">
-                <a16:creationId xmlns:a16="http://schemas.microsoft.com/office/drawing/2014/main" id="{3114FDBF-587C-4AFC-9843-2F6B8CC7EDDB}"/>
+                <a16:creationId xmlns:a16="http://schemas.microsoft.com/office/drawing/2014/main" id="{5537AA39-79B5-4A2C-8680-EED486A6D29B}"/>
               </a:ext>
             </a:extLst>
           </p:cNvPr>
@@ -6917,7 +6917,7 @@
           <p:cNvPr id="8" name="">
             <a:extLst xmlns:a="http://schemas.openxmlformats.org/drawingml/2006/main">
               <a:ext uri="{FF2B5EF4-FFF2-40B4-BE49-F238E27FC236}">
-                <a16:creationId xmlns:a16="http://schemas.microsoft.com/office/drawing/2014/main" id="{7417A284-AC87-4642-995E-334CA2E8106C}"/>
+                <a16:creationId xmlns:a16="http://schemas.microsoft.com/office/drawing/2014/main" id="{E3159583-3C03-4D46-9172-15D7FC521E43}"/>
               </a:ext>
             </a:extLst>
           </p:cNvPr>
@@ -6967,7 +6967,7 @@
           <p:cNvPr id="9" name="">
             <a:extLst xmlns:a="http://schemas.openxmlformats.org/drawingml/2006/main">
               <a:ext uri="{FF2B5EF4-FFF2-40B4-BE49-F238E27FC236}">
-                <a16:creationId xmlns:a16="http://schemas.microsoft.com/office/drawing/2014/main" id="{2E4EBE1E-CC05-474C-BF83-49DE0203A87B}"/>
+                <a16:creationId xmlns:a16="http://schemas.microsoft.com/office/drawing/2014/main" id="{290427CD-7522-4508-9B0B-9BBB55ED0161}"/>
               </a:ext>
             </a:extLst>
           </p:cNvPr>
@@ -7000,7 +7000,7 @@
           <p:cNvPr id="10" name="">
             <a:extLst xmlns:a="http://schemas.openxmlformats.org/drawingml/2006/main">
               <a:ext uri="{FF2B5EF4-FFF2-40B4-BE49-F238E27FC236}">
-                <a16:creationId xmlns:a16="http://schemas.microsoft.com/office/drawing/2014/main" id="{AE77DE19-B639-446E-AE73-F8CE6FF450E0}"/>
+                <a16:creationId xmlns:a16="http://schemas.microsoft.com/office/drawing/2014/main" id="{1CC9560B-5C99-4B04-9DFF-4270A28C0D86}"/>
               </a:ext>
             </a:extLst>
           </p:cNvPr>
@@ -7050,7 +7050,7 @@
           <p:cNvPr id="11" name="">
             <a:extLst xmlns:a="http://schemas.openxmlformats.org/drawingml/2006/main">
               <a:ext uri="{FF2B5EF4-FFF2-40B4-BE49-F238E27FC236}">
-                <a16:creationId xmlns:a16="http://schemas.microsoft.com/office/drawing/2014/main" id="{197009EE-05F5-4370-836A-0A27218F3D36}"/>
+                <a16:creationId xmlns:a16="http://schemas.microsoft.com/office/drawing/2014/main" id="{9A01C045-692B-4ABC-ACF2-BC19FCBDECF6}"/>
               </a:ext>
             </a:extLst>
           </p:cNvPr>
@@ -7083,7 +7083,7 @@
           <p:cNvPr id="12" name="">
             <a:extLst xmlns:a="http://schemas.openxmlformats.org/drawingml/2006/main">
               <a:ext uri="{FF2B5EF4-FFF2-40B4-BE49-F238E27FC236}">
-                <a16:creationId xmlns:a16="http://schemas.microsoft.com/office/drawing/2014/main" id="{26DB7625-D9AE-4145-B79F-1CE264BA180D}"/>
+                <a16:creationId xmlns:a16="http://schemas.microsoft.com/office/drawing/2014/main" id="{88D24093-0CFC-4C39-9072-D4F33919BBD1}"/>
               </a:ext>
             </a:extLst>
           </p:cNvPr>
@@ -7133,7 +7133,7 @@
           <p:cNvPr id="13" name="">
             <a:extLst xmlns:a="http://schemas.openxmlformats.org/drawingml/2006/main">
               <a:ext uri="{FF2B5EF4-FFF2-40B4-BE49-F238E27FC236}">
-                <a16:creationId xmlns:a16="http://schemas.microsoft.com/office/drawing/2014/main" id="{8CFB0A58-71BD-4EE9-B704-370E4BF470C5}"/>
+                <a16:creationId xmlns:a16="http://schemas.microsoft.com/office/drawing/2014/main" id="{00976ED2-9AF1-4767-9647-A94C2307D291}"/>
               </a:ext>
             </a:extLst>
           </p:cNvPr>
@@ -7183,7 +7183,7 @@
           <p:cNvPr id="14" name="">
             <a:extLst xmlns:a="http://schemas.openxmlformats.org/drawingml/2006/main">
               <a:ext uri="{FF2B5EF4-FFF2-40B4-BE49-F238E27FC236}">
-                <a16:creationId xmlns:a16="http://schemas.microsoft.com/office/drawing/2014/main" id="{2B93F06D-3278-4847-B3C8-061454C56682}"/>
+                <a16:creationId xmlns:a16="http://schemas.microsoft.com/office/drawing/2014/main" id="{972D0090-92FA-42FD-A1F3-9FFFEA4A6A98}"/>
               </a:ext>
             </a:extLst>
           </p:cNvPr>
@@ -7216,7 +7216,7 @@
           <p:cNvPr id="15" name="">
             <a:extLst xmlns:a="http://schemas.openxmlformats.org/drawingml/2006/main">
               <a:ext uri="{FF2B5EF4-FFF2-40B4-BE49-F238E27FC236}">
-                <a16:creationId xmlns:a16="http://schemas.microsoft.com/office/drawing/2014/main" id="{5896A90D-9827-4CE0-8AD2-762F9F1C18EE}"/>
+                <a16:creationId xmlns:a16="http://schemas.microsoft.com/office/drawing/2014/main" id="{0EB10767-6341-4D76-A2D8-64A45E922F26}"/>
               </a:ext>
             </a:extLst>
           </p:cNvPr>
@@ -7266,7 +7266,7 @@
           <p:cNvPr id="16" name="">
             <a:extLst xmlns:a="http://schemas.openxmlformats.org/drawingml/2006/main">
               <a:ext uri="{FF2B5EF4-FFF2-40B4-BE49-F238E27FC236}">
-                <a16:creationId xmlns:a16="http://schemas.microsoft.com/office/drawing/2014/main" id="{F3B46E45-EF78-4CF7-8622-F8CCD3FE032D}"/>
+                <a16:creationId xmlns:a16="http://schemas.microsoft.com/office/drawing/2014/main" id="{EBF90618-B379-47AB-BCA7-8162AE41935A}"/>
               </a:ext>
             </a:extLst>
           </p:cNvPr>
@@ -7306,7 +7306,7 @@
                   <a:srgbClr val="4B5563"/>
                 </a:solidFill>
               </a:rPr>
-              <a:t>Future model</a:t>
+              <a:t>Next pose model</a:t>
             </a:r>
           </a:p>
         </p:txBody>
@@ -7316,7 +7316,7 @@
           <p:cNvPr id="17" name="">
             <a:extLst xmlns:a="http://schemas.openxmlformats.org/drawingml/2006/main">
               <a:ext uri="{FF2B5EF4-FFF2-40B4-BE49-F238E27FC236}">
-                <a16:creationId xmlns:a16="http://schemas.microsoft.com/office/drawing/2014/main" id="{CB6DE144-E521-4AC2-AC8F-043D804956D2}"/>
+                <a16:creationId xmlns:a16="http://schemas.microsoft.com/office/drawing/2014/main" id="{F0FE2D54-8EC3-4A5A-9824-40EC9767EB57}"/>
               </a:ext>
             </a:extLst>
           </p:cNvPr>
@@ -7364,7 +7364,7 @@
     </p:spTree>
     <p:extLst>
       <p:ext uri="{BB962C8B-B14F-4D97-AF65-F5344CB8AC3E}">
-        <p14:creationId xmlns:p14="http://schemas.microsoft.com/office/powerpoint/2010/main" val="1295613346"/>
+        <p14:creationId xmlns:p14="http://schemas.microsoft.com/office/powerpoint/2010/main" val="511731071"/>
       </p:ext>
     </p:extLst>
   </p:cSld>

</xml_diff>